<commit_message>
Slides 6-7: risk groups and limits match the current rule and holdout
Co-Authored-By: Claude Opus 5.5 <noreply@anthropic.com>
</commit_message>
<xml_diff>
--- a/presentation/talk.pptx
+++ b/presentation/talk.pptx
@@ -5377,7 +5377,7 @@
                         </a:defRPr>
                       </a:pPr>
                       <a:r>
-                        <a:t>167</a:t>
+                        <a:t>169</a:t>
                       </a:r>
                     </a:p>
                   </a:txBody>
@@ -5396,7 +5396,7 @@
                         </a:defRPr>
                       </a:pPr>
                       <a:r>
-                        <a:t>13.63</a:t>
+                        <a:t>13.57</a:t>
                       </a:r>
                     </a:p>
                   </a:txBody>
@@ -5436,7 +5436,7 @@
                         </a:defRPr>
                       </a:pPr>
                       <a:r>
-                        <a:t>91</a:t>
+                        <a:t>77</a:t>
                       </a:r>
                     </a:p>
                   </a:txBody>
@@ -5455,7 +5455,7 @@
                         </a:defRPr>
                       </a:pPr>
                       <a:r>
-                        <a:t>11.65</a:t>
+                        <a:t>11.60</a:t>
                       </a:r>
                     </a:p>
                   </a:txBody>
@@ -5495,7 +5495,7 @@
                         </a:defRPr>
                       </a:pPr>
                       <a:r>
-                        <a:t>137</a:t>
+                        <a:t>149</a:t>
                       </a:r>
                     </a:p>
                   </a:txBody>
@@ -5514,7 +5514,7 @@
                         </a:defRPr>
                       </a:pPr>
                       <a:r>
-                        <a:t>5.68</a:t>
+                        <a:t>6.22</a:t>
                       </a:r>
                     </a:p>
                   </a:txBody>
@@ -5564,7 +5564,7 @@
                   <a:srgbClr val="222222"/>
                 </a:solidFill>
               </a:rPr>
-              <a:t>One subject and one year (Portuguese math cohort)</a:t>
+              <a:t>Main analysis: one maths class, one year (Portugal)</a:t>
             </a:r>
           </a:p>
           <a:p>
@@ -5606,7 +5606,7 @@
                   <a:srgbClr val="222222"/>
                 </a:solidFill>
               </a:rPr>
-              <a:t>No holdout test: the risk rule is not validated on new students</a:t>
+              <a:t>Tested on 275 new students (Portuguese class, not in maths): 64 of 97 flagged failed; 64 of 70 who failed were flagged</a:t>
             </a:r>
           </a:p>
           <a:p>
@@ -5627,7 +5627,7 @@
                   <a:srgbClr val="222222"/>
                 </a:solidFill>
               </a:rPr>
-              <a:t>High group is defined partly by G3 (G3 &lt; 10 or 2+ failures), so its gap is not an independent prediction</a:t>
+              <a:t>The rule uses only G1, G2, failures and absences, never G3, so it can warn before the final exam</a:t>
             </a:r>
           </a:p>
         </p:txBody>
@@ -5722,7 +5722,7 @@
                   <a:srgbClr val="222222"/>
                 </a:solidFill>
               </a:rPr>
-              <a:t>Add student-por.csv with a subject column, to test whether the pattern holds in a second subject</a:t>
+              <a:t>Ask why 38 students scored 0: missed the exam or dropped out?</a:t>
             </a:r>
           </a:p>
           <a:p>
@@ -5764,7 +5764,7 @@
                   <a:srgbClr val="222222"/>
                 </a:solidFill>
               </a:rPr>
-              <a:t>Validate the risk rule out-of-sample before any school use</a:t>
+              <a:t>Test the rule on another school or year before any school use</a:t>
             </a:r>
           </a:p>
         </p:txBody>

</xml_diff>